<commit_message>
fix the build_deck.js script to correctly generate the Qoneqt-Video-Factory deck in both PDF and PPTX formats. Updated the script to handle new slide layouts and ensure compatibility with the latest version of the deck generator.
</commit_message>
<xml_diff>
--- a/docs/deck/Qoneqt-Video-Factory.pptx
+++ b/docs/deck/Qoneqt-Video-Factory.pptx
@@ -1683,13 +1683,13 @@
             <a:r>
               <a:rPr lang="en-US" sz="1600" b="1" dirty="0">
                 <a:solidFill>
-                  <a:srgbClr val="FFE500"/>
-                </a:solidFill>
-                <a:latin typeface="Calibri" pitchFamily="34" charset="0"/>
-                <a:ea typeface="Calibri" pitchFamily="34" charset="-122"/>
-                <a:cs typeface="Calibri" pitchFamily="34" charset="-120"/>
-              </a:rPr>
-              <a:t>[Team Name]  ·  [Team ID]</a:t>
+                  <a:srgbClr val="FFFFFF"/>
+                </a:solidFill>
+                <a:latin typeface="Calibri" pitchFamily="34" charset="0"/>
+                <a:ea typeface="Calibri" pitchFamily="34" charset="-122"/>
+                <a:cs typeface="Calibri" pitchFamily="34" charset="-120"/>
+              </a:rPr>
+              <a:t>ProCoders</a:t>
             </a:r>
             <a:endParaRPr lang="en-US" sz="1600" dirty="0"/>
           </a:p>
@@ -1761,13 +1761,13 @@
             <a:r>
               <a:rPr lang="en-US" sz="1300" dirty="0">
                 <a:solidFill>
-                  <a:srgbClr val="FFE500"/>
-                </a:solidFill>
-                <a:latin typeface="Calibri" pitchFamily="34" charset="0"/>
-                <a:ea typeface="Calibri" pitchFamily="34" charset="-122"/>
-                <a:cs typeface="Calibri" pitchFamily="34" charset="-120"/>
-              </a:rPr>
-              <a:t>[College Name]</a:t>
+                  <a:srgbClr val="F3EEFC"/>
+                </a:solidFill>
+                <a:latin typeface="Calibri" pitchFamily="34" charset="0"/>
+                <a:ea typeface="Calibri" pitchFamily="34" charset="-122"/>
+                <a:cs typeface="Calibri" pitchFamily="34" charset="-120"/>
+              </a:rPr>
+              <a:t>LJ University</a:t>
             </a:r>
             <a:endParaRPr lang="en-US" sz="1300" dirty="0"/>
           </a:p>
@@ -7038,7 +7038,7 @@
                 <a:ea typeface="Calibri" pitchFamily="34" charset="-122"/>
                 <a:cs typeface="Calibri" pitchFamily="34" charset="-120"/>
               </a:rPr>
-              <a:t>Outputs as files (mp4, jpg, json). Docker image with ffmpeg and Noto fonts. Deployed on a free Hugging Face Space, keys as secrets.</a:t>
+              <a:t>Outputs as files (mp4, jpg, json). Docker image with ffmpeg and Noto fonts. Deployed on Railway, keys as secrets.</a:t>
             </a:r>
             <a:endParaRPr lang="en-US" sz="950" dirty="0"/>
           </a:p>
@@ -7091,7 +7091,7 @@
                 <a:ea typeface="Calibri" pitchFamily="34" charset="-122"/>
                 <a:cs typeface="Calibri" pitchFamily="34" charset="-120"/>
               </a:rPr>
-              <a:t>Python 3.11 · FastAPI · httpx · ffmpeg · Docker · Groq (gpt-oss-120b, Whisper large-v3-turbo) · Pollinations FLUX · Hugging Face Spaces · ElevenLabs · edge-tts · Wikimedia Commons</a:t>
+              <a:t>Python 3.11 · FastAPI · httpx · ffmpeg · Docker · Groq (gpt-oss-120b, Whisper large-v3-turbo) · Pollinations FLUX · Railway · ElevenLabs · edge-tts · Wikimedia Commons</a:t>
             </a:r>
             <a:endParaRPr lang="en-US" sz="1050" dirty="0"/>
           </a:p>
@@ -9246,7 +9246,7 @@
                 <a:ea typeface="Calibri" pitchFamily="34" charset="-122"/>
                 <a:cs typeface="Calibri" pitchFamily="34" charset="-120"/>
               </a:rPr>
-              <a:t>One Docker container on a free Hugging Face Space; keys stay secret</a:t>
+              <a:t>One Docker container on Railway; keys stay secret</a:t>
             </a:r>
             <a:endParaRPr lang="en-US" sz="1050" dirty="0"/>
           </a:p>
@@ -9267,7 +9267,7 @@
                 <a:ea typeface="Calibri" pitchFamily="34" charset="-122"/>
                 <a:cs typeface="Calibri" pitchFamily="34" charset="-120"/>
               </a:rPr>
-              <a:t>Working end to end today; live URL and Global Feed post by the finale</a:t>
+              <a:t>Working end to end today and live on a public URL</a:t>
             </a:r>
             <a:endParaRPr lang="en-US" sz="1050" dirty="0"/>
           </a:p>
@@ -9539,8 +9539,8 @@
         </p:nvSpPr>
         <p:spPr>
           <a:xfrm>
-            <a:off x="4023360" y="1508760"/>
-            <a:ext cx="4663440" cy="1143000"/>
+            <a:off x="4023360" y="1481328"/>
+            <a:ext cx="4663440" cy="777240"/>
           </a:xfrm>
           <a:prstGeom prst="rect">
             <a:avLst/>
@@ -9560,7 +9560,7 @@
               <a:buChar char="•"/>
             </a:pPr>
             <a:r>
-              <a:rPr lang="en-US" sz="1050" dirty="0">
+              <a:rPr lang="en-US" sz="950" dirty="0">
                 <a:solidFill>
                   <a:srgbClr val="F3EEFC"/>
                 </a:solidFill>
@@ -9568,9 +9568,9 @@
                 <a:ea typeface="Calibri" pitchFamily="34" charset="-122"/>
                 <a:cs typeface="Calibri" pitchFamily="34" charset="-120"/>
               </a:rPr>
-              <a:t>Batch of three topics queued from the page; each ran plan → images → voice → visuals → captions → render with live progress</a:t>
-            </a:r>
-            <a:endParaRPr lang="en-US" sz="1050" dirty="0"/>
+              <a:t>Batch of topics queued from the page; each runs plan → images → voice → visuals → captions → render with live progress</a:t>
+            </a:r>
+            <a:endParaRPr lang="en-US" sz="950" dirty="0"/>
           </a:p>
           <a:p>
             <a:pPr marL="342900" indent="-342900">
@@ -9581,7 +9581,7 @@
               <a:buChar char="•"/>
             </a:pPr>
             <a:r>
-              <a:rPr lang="en-US" sz="1050" dirty="0">
+              <a:rPr lang="en-US" sz="950" dirty="0">
                 <a:solidFill>
                   <a:srgbClr val="F3EEFC"/>
                 </a:solidFill>
@@ -9589,30 +9589,9 @@
                 <a:ea typeface="Calibri" pitchFamily="34" charset="-122"/>
                 <a:cs typeface="Calibri" pitchFamily="34" charset="-120"/>
               </a:rPr>
-              <a:t>34-second videos produced in about 55 seconds each, ElevenLabs voice, word-pop captions, post text ready to copy</a:t>
-            </a:r>
-            <a:endParaRPr lang="en-US" sz="1050" dirty="0"/>
-          </a:p>
-          <a:p>
-            <a:pPr marL="342900" indent="-342900">
-              <a:spcAft>
-                <a:spcPts val="400"/>
-              </a:spcAft>
-              <a:buSzPct val="100000"/>
-              <a:buChar char="•"/>
-            </a:pPr>
-            <a:r>
-              <a:rPr lang="en-US" sz="1050" dirty="0">
-                <a:solidFill>
-                  <a:srgbClr val="F3EEFC"/>
-                </a:solidFill>
-                <a:latin typeface="Calibri" pitchFamily="34" charset="0"/>
-                <a:ea typeface="Calibri" pitchFamily="34" charset="-122"/>
-                <a:cs typeface="Calibri" pitchFamily="34" charset="-120"/>
-              </a:rPr>
-              <a:t>Hinglish preset verified on the fallback voice; every stage's fallback exercised</a:t>
-            </a:r>
-            <a:endParaRPr lang="en-US" sz="1050" dirty="0"/>
+              <a:t>34-second videos in about 55 seconds each, word-pop captions, post text ready to copy</a:t>
+            </a:r>
+            <a:endParaRPr lang="en-US" sz="950" dirty="0"/>
           </a:p>
         </p:txBody>
       </p:sp>
@@ -9624,12 +9603,12 @@
         </p:nvSpPr>
         <p:spPr>
           <a:xfrm>
-            <a:off x="4023360" y="2697480"/>
-            <a:ext cx="4663440" cy="868680"/>
+            <a:off x="4023360" y="2240280"/>
+            <a:ext cx="4663440" cy="1234440"/>
           </a:xfrm>
           <a:prstGeom prst="roundRect">
             <a:avLst>
-              <a:gd name="adj" fmla="val 10526"/>
+              <a:gd name="adj" fmla="val 7407"/>
             </a:avLst>
           </a:prstGeom>
           <a:solidFill>
@@ -9655,8 +9634,8 @@
         </p:nvSpPr>
         <p:spPr>
           <a:xfrm>
-            <a:off x="4160520" y="2761488"/>
-            <a:ext cx="4389120" cy="731520"/>
+            <a:off x="4160520" y="2304288"/>
+            <a:ext cx="4389120" cy="292608"/>
           </a:xfrm>
           <a:prstGeom prst="rect">
             <a:avLst/>
@@ -9672,97 +9651,497 @@
               <a:buNone/>
             </a:pPr>
             <a:r>
-              <a:rPr lang="en-US" sz="1050" b="1" dirty="0">
+              <a:rPr lang="en-US" sz="1200" b="1" dirty="0">
+                <a:solidFill>
+                  <a:srgbClr val="FFFFFF"/>
+                </a:solidFill>
+                <a:latin typeface="Calibri" pitchFamily="34" charset="0"/>
+                <a:ea typeface="Calibri" pitchFamily="34" charset="-122"/>
+                <a:cs typeface="Calibri" pitchFamily="34" charset="-120"/>
+              </a:rPr>
+              <a:t>Try the live demo in 3 steps</a:t>
+            </a:r>
+            <a:endParaRPr lang="en-US" sz="1200" dirty="0"/>
+          </a:p>
+        </p:txBody>
+      </p:sp>
+      <p:sp>
+        <p:nvSpPr>
+          <p:cNvPr id="11" name="Shape 8"/>
+          <p:cNvSpPr/>
+          <p:nvPr/>
+        </p:nvSpPr>
+        <p:spPr>
+          <a:xfrm>
+            <a:off x="4160520" y="2615184"/>
+            <a:ext cx="219456" cy="219456"/>
+          </a:xfrm>
+          <a:prstGeom prst="ellipse">
+            <a:avLst/>
+          </a:prstGeom>
+          <a:solidFill>
+            <a:srgbClr val="8B5CF6"/>
+          </a:solidFill>
+          <a:ln w="12700">
+            <a:solidFill>
+              <a:srgbClr val="8B5CF6"/>
+            </a:solidFill>
+            <a:prstDash val="solid"/>
+          </a:ln>
+        </p:spPr>
+      </p:sp>
+      <p:sp>
+        <p:nvSpPr>
+          <p:cNvPr id="12" name="Text 9"/>
+          <p:cNvSpPr txBox="1"/>
+          <p:nvPr/>
+        </p:nvSpPr>
+        <p:spPr>
+          <a:xfrm>
+            <a:off x="4160520" y="2615184"/>
+            <a:ext cx="219456" cy="219456"/>
+          </a:xfrm>
+          <a:prstGeom prst="rect">
+            <a:avLst/>
+          </a:prstGeom>
+          <a:noFill/>
+          <a:ln/>
+        </p:spPr>
+        <p:txBody>
+          <a:bodyPr wrap="square" lIns="0" tIns="0" rIns="0" bIns="0" rtlCol="0" anchor="ctr"/>
+          <a:lstStyle/>
+          <a:p>
+            <a:pPr algn="ctr" indent="0" marL="0">
+              <a:buNone/>
+            </a:pPr>
+            <a:r>
+              <a:rPr lang="en-US" sz="1300" b="1" dirty="0">
+                <a:solidFill>
+                  <a:srgbClr val="FFFFFF"/>
+                </a:solidFill>
+                <a:latin typeface="Calibri" pitchFamily="34" charset="0"/>
+                <a:ea typeface="Calibri" pitchFamily="34" charset="-122"/>
+                <a:cs typeface="Calibri" pitchFamily="34" charset="-120"/>
+              </a:rPr>
+              <a:t>1</a:t>
+            </a:r>
+            <a:endParaRPr lang="en-US" sz="1300" dirty="0"/>
+          </a:p>
+        </p:txBody>
+      </p:sp>
+      <p:sp>
+        <p:nvSpPr>
+          <p:cNvPr id="13" name="Text 10"/>
+          <p:cNvSpPr txBox="1"/>
+          <p:nvPr/>
+        </p:nvSpPr>
+        <p:spPr>
+          <a:xfrm>
+            <a:off x="4462272" y="2615184"/>
+            <a:ext cx="4114800" cy="219456"/>
+          </a:xfrm>
+          <a:prstGeom prst="rect">
+            <a:avLst/>
+          </a:prstGeom>
+          <a:noFill/>
+          <a:ln/>
+        </p:spPr>
+        <p:txBody>
+          <a:bodyPr wrap="square" lIns="0" tIns="0" rIns="0" bIns="0" rtlCol="0" anchor="ctr"/>
+          <a:lstStyle/>
+          <a:p>
+            <a:pPr indent="0" marL="0">
+              <a:buNone/>
+            </a:pPr>
+            <a:r>
+              <a:rPr lang="en-US" sz="950" b="1" dirty="0">
+                <a:solidFill>
+                  <a:srgbClr val="FFFFFF"/>
+                </a:solidFill>
+                <a:latin typeface="Calibri" pitchFamily="34" charset="0"/>
+                <a:ea typeface="Calibri" pitchFamily="34" charset="-122"/>
+                <a:cs typeface="Calibri" pitchFamily="34" charset="-120"/>
+              </a:rPr>
+              <a:t>Write a prompt  </a:t>
+            </a:r>
+            <a:pPr indent="0" marL="0">
+              <a:buNone/>
+            </a:pPr>
+            <a:r>
+              <a:rPr lang="en-US" sz="950" dirty="0">
+                <a:solidFill>
+                  <a:srgbClr val="A89CC4"/>
+                </a:solidFill>
+                <a:latin typeface="Calibri" pitchFamily="34" charset="0"/>
+                <a:ea typeface="Calibri" pitchFamily="34" charset="-122"/>
+                <a:cs typeface="Calibri" pitchFamily="34" charset="-120"/>
+              </a:rPr>
+              <a:t>e.g. “AI use cases in daily life” (one topic per line)</a:t>
+            </a:r>
+            <a:endParaRPr lang="en-US" sz="950" dirty="0"/>
+          </a:p>
+        </p:txBody>
+      </p:sp>
+      <p:sp>
+        <p:nvSpPr>
+          <p:cNvPr id="14" name="Shape 11"/>
+          <p:cNvSpPr/>
+          <p:nvPr/>
+        </p:nvSpPr>
+        <p:spPr>
+          <a:xfrm>
+            <a:off x="4160520" y="2889504"/>
+            <a:ext cx="219456" cy="219456"/>
+          </a:xfrm>
+          <a:prstGeom prst="ellipse">
+            <a:avLst/>
+          </a:prstGeom>
+          <a:solidFill>
+            <a:srgbClr val="8B5CF6"/>
+          </a:solidFill>
+          <a:ln w="12700">
+            <a:solidFill>
+              <a:srgbClr val="8B5CF6"/>
+            </a:solidFill>
+            <a:prstDash val="solid"/>
+          </a:ln>
+        </p:spPr>
+      </p:sp>
+      <p:sp>
+        <p:nvSpPr>
+          <p:cNvPr id="15" name="Text 12"/>
+          <p:cNvSpPr txBox="1"/>
+          <p:nvPr/>
+        </p:nvSpPr>
+        <p:spPr>
+          <a:xfrm>
+            <a:off x="4160520" y="2889504"/>
+            <a:ext cx="219456" cy="219456"/>
+          </a:xfrm>
+          <a:prstGeom prst="rect">
+            <a:avLst/>
+          </a:prstGeom>
+          <a:noFill/>
+          <a:ln/>
+        </p:spPr>
+        <p:txBody>
+          <a:bodyPr wrap="square" lIns="0" tIns="0" rIns="0" bIns="0" rtlCol="0" anchor="ctr"/>
+          <a:lstStyle/>
+          <a:p>
+            <a:pPr algn="ctr" indent="0" marL="0">
+              <a:buNone/>
+            </a:pPr>
+            <a:r>
+              <a:rPr lang="en-US" sz="1300" b="1" dirty="0">
+                <a:solidFill>
+                  <a:srgbClr val="FFFFFF"/>
+                </a:solidFill>
+                <a:latin typeface="Calibri" pitchFamily="34" charset="0"/>
+                <a:ea typeface="Calibri" pitchFamily="34" charset="-122"/>
+                <a:cs typeface="Calibri" pitchFamily="34" charset="-120"/>
+              </a:rPr>
+              <a:t>2</a:t>
+            </a:r>
+            <a:endParaRPr lang="en-US" sz="1300" dirty="0"/>
+          </a:p>
+        </p:txBody>
+      </p:sp>
+      <p:sp>
+        <p:nvSpPr>
+          <p:cNvPr id="16" name="Text 13"/>
+          <p:cNvSpPr txBox="1"/>
+          <p:nvPr/>
+        </p:nvSpPr>
+        <p:spPr>
+          <a:xfrm>
+            <a:off x="4462272" y="2889504"/>
+            <a:ext cx="4114800" cy="219456"/>
+          </a:xfrm>
+          <a:prstGeom prst="rect">
+            <a:avLst/>
+          </a:prstGeom>
+          <a:noFill/>
+          <a:ln/>
+        </p:spPr>
+        <p:txBody>
+          <a:bodyPr wrap="square" lIns="0" tIns="0" rIns="0" bIns="0" rtlCol="0" anchor="ctr"/>
+          <a:lstStyle/>
+          <a:p>
+            <a:pPr indent="0" marL="0">
+              <a:buNone/>
+            </a:pPr>
+            <a:r>
+              <a:rPr lang="en-US" sz="950" b="1" dirty="0">
+                <a:solidFill>
+                  <a:srgbClr val="FFFFFF"/>
+                </a:solidFill>
+                <a:latin typeface="Calibri" pitchFamily="34" charset="0"/>
+                <a:ea typeface="Calibri" pitchFamily="34" charset="-122"/>
+                <a:cs typeface="Calibri" pitchFamily="34" charset="-120"/>
+              </a:rPr>
+              <a:t>Select a category  </a:t>
+            </a:r>
+            <a:pPr indent="0" marL="0">
+              <a:buNone/>
+            </a:pPr>
+            <a:r>
+              <a:rPr lang="en-US" sz="950" dirty="0">
+                <a:solidFill>
+                  <a:srgbClr val="A89CC4"/>
+                </a:solidFill>
+                <a:latin typeface="Calibri" pitchFamily="34" charset="0"/>
+                <a:ea typeface="Calibri" pitchFamily="34" charset="-122"/>
+                <a:cs typeface="Calibri" pitchFamily="34" charset="-120"/>
+              </a:rPr>
+              <a:t>pick a community: Tech, Fitness, Hinglish Fun…</a:t>
+            </a:r>
+            <a:endParaRPr lang="en-US" sz="950" dirty="0"/>
+          </a:p>
+        </p:txBody>
+      </p:sp>
+      <p:sp>
+        <p:nvSpPr>
+          <p:cNvPr id="17" name="Shape 14"/>
+          <p:cNvSpPr/>
+          <p:nvPr/>
+        </p:nvSpPr>
+        <p:spPr>
+          <a:xfrm>
+            <a:off x="4160520" y="3163824"/>
+            <a:ext cx="219456" cy="219456"/>
+          </a:xfrm>
+          <a:prstGeom prst="ellipse">
+            <a:avLst/>
+          </a:prstGeom>
+          <a:solidFill>
+            <a:srgbClr val="8B5CF6"/>
+          </a:solidFill>
+          <a:ln w="12700">
+            <a:solidFill>
+              <a:srgbClr val="8B5CF6"/>
+            </a:solidFill>
+            <a:prstDash val="solid"/>
+          </a:ln>
+        </p:spPr>
+      </p:sp>
+      <p:sp>
+        <p:nvSpPr>
+          <p:cNvPr id="18" name="Text 15"/>
+          <p:cNvSpPr txBox="1"/>
+          <p:nvPr/>
+        </p:nvSpPr>
+        <p:spPr>
+          <a:xfrm>
+            <a:off x="4160520" y="3163824"/>
+            <a:ext cx="219456" cy="219456"/>
+          </a:xfrm>
+          <a:prstGeom prst="rect">
+            <a:avLst/>
+          </a:prstGeom>
+          <a:noFill/>
+          <a:ln/>
+        </p:spPr>
+        <p:txBody>
+          <a:bodyPr wrap="square" lIns="0" tIns="0" rIns="0" bIns="0" rtlCol="0" anchor="ctr"/>
+          <a:lstStyle/>
+          <a:p>
+            <a:pPr algn="ctr" indent="0" marL="0">
+              <a:buNone/>
+            </a:pPr>
+            <a:r>
+              <a:rPr lang="en-US" sz="1300" b="1" dirty="0">
+                <a:solidFill>
+                  <a:srgbClr val="FFFFFF"/>
+                </a:solidFill>
+                <a:latin typeface="Calibri" pitchFamily="34" charset="0"/>
+                <a:ea typeface="Calibri" pitchFamily="34" charset="-122"/>
+                <a:cs typeface="Calibri" pitchFamily="34" charset="-120"/>
+              </a:rPr>
+              <a:t>3</a:t>
+            </a:r>
+            <a:endParaRPr lang="en-US" sz="1300" dirty="0"/>
+          </a:p>
+        </p:txBody>
+      </p:sp>
+      <p:sp>
+        <p:nvSpPr>
+          <p:cNvPr id="19" name="Text 16"/>
+          <p:cNvSpPr txBox="1"/>
+          <p:nvPr/>
+        </p:nvSpPr>
+        <p:spPr>
+          <a:xfrm>
+            <a:off x="4462272" y="3163824"/>
+            <a:ext cx="4114800" cy="219456"/>
+          </a:xfrm>
+          <a:prstGeom prst="rect">
+            <a:avLst/>
+          </a:prstGeom>
+          <a:noFill/>
+          <a:ln/>
+        </p:spPr>
+        <p:txBody>
+          <a:bodyPr wrap="square" lIns="0" tIns="0" rIns="0" bIns="0" rtlCol="0" anchor="ctr"/>
+          <a:lstStyle/>
+          <a:p>
+            <a:pPr indent="0" marL="0">
+              <a:buNone/>
+            </a:pPr>
+            <a:r>
+              <a:rPr lang="en-US" sz="950" b="1" dirty="0">
+                <a:solidFill>
+                  <a:srgbClr val="FFFFFF"/>
+                </a:solidFill>
+                <a:latin typeface="Calibri" pitchFamily="34" charset="0"/>
+                <a:ea typeface="Calibri" pitchFamily="34" charset="-122"/>
+                <a:cs typeface="Calibri" pitchFamily="34" charset="-120"/>
+              </a:rPr>
+              <a:t>Press Start  </a:t>
+            </a:r>
+            <a:pPr indent="0" marL="0">
+              <a:buNone/>
+            </a:pPr>
+            <a:r>
+              <a:rPr lang="en-US" sz="950" dirty="0">
+                <a:solidFill>
+                  <a:srgbClr val="A89CC4"/>
+                </a:solidFill>
+                <a:latin typeface="Calibri" pitchFamily="34" charset="0"/>
+                <a:ea typeface="Calibri" pitchFamily="34" charset="-122"/>
+                <a:cs typeface="Calibri" pitchFamily="34" charset="-120"/>
+              </a:rPr>
+              <a:t>watch the stages run; the video is ready in ~1 min</a:t>
+            </a:r>
+            <a:endParaRPr lang="en-US" sz="950" dirty="0"/>
+          </a:p>
+        </p:txBody>
+      </p:sp>
+      <p:sp>
+        <p:nvSpPr>
+          <p:cNvPr id="20" name="Text 17"/>
+          <p:cNvSpPr/>
+          <p:nvPr/>
+        </p:nvSpPr>
+        <p:spPr>
+          <a:xfrm>
+            <a:off x="4023360" y="3611880"/>
+            <a:ext cx="1828800" cy="365760"/>
+          </a:xfrm>
+          <a:prstGeom prst="roundRect">
+            <a:avLst>
+              <a:gd name="adj" fmla="val 20000"/>
+            </a:avLst>
+          </a:prstGeom>
+          <a:solidFill>
+            <a:srgbClr val="FFE500"/>
+          </a:solidFill>
+          <a:ln>
+            <a:solidFill>
+              <a:srgbClr val="FFE500"/>
+            </a:solidFill>
+          </a:ln>
+        </p:spPr>
+        <p:txBody>
+          <a:bodyPr wrap="square" lIns="0" tIns="0" rIns="0" bIns="0" rtlCol="0" anchor="ctr"/>
+          <a:lstStyle/>
+          <a:p>
+            <a:pPr algn="ctr" indent="0" marL="0">
+              <a:buNone/>
+            </a:pPr>
+            <a:r>
+              <a:rPr lang="en-US" sz="1200" b="1" u="sng" dirty="0">
+                <a:solidFill>
+                  <a:srgbClr val="0B0416"/>
+                </a:solidFill>
+                <a:latin typeface="Calibri" pitchFamily="34" charset="0"/>
+                <a:ea typeface="Calibri" pitchFamily="34" charset="-122"/>
+                <a:cs typeface="Calibri" pitchFamily="34" charset="-120"/>
+                <a:hlinkClick r:id="rId3" invalidUrl="" action="" tgtFrame="" tooltip="https://qoneqt-video-factory.up.railway.app/" history="1" highlightClick="0" endSnd="0">
+                  <a:extLst>
+                    <a:ext uri="{A12FA001-AC4F-418D-AE19-62706E023703}">
+                      <ahyp:hlinkClr xmlns:ahyp="http://schemas.microsoft.com/office/drawing/2018/hyperlinkcolor" val="tx"/>
+                    </a:ext>
+                  </a:extLst>
+                </a:hlinkClick>
+              </a:rPr>
+              <a:t>▶  Open Live Demo</a:t>
+            </a:r>
+            <a:endParaRPr lang="en-US" sz="1200" dirty="0"/>
+          </a:p>
+        </p:txBody>
+      </p:sp>
+      <p:sp>
+        <p:nvSpPr>
+          <p:cNvPr id="21" name="Text 18"/>
+          <p:cNvSpPr txBox="1"/>
+          <p:nvPr/>
+        </p:nvSpPr>
+        <p:spPr>
+          <a:xfrm>
+            <a:off x="5989320" y="3584448"/>
+            <a:ext cx="2697480" cy="420624"/>
+          </a:xfrm>
+          <a:prstGeom prst="rect">
+            <a:avLst/>
+          </a:prstGeom>
+          <a:noFill/>
+          <a:ln/>
+        </p:spPr>
+        <p:txBody>
+          <a:bodyPr wrap="square" lIns="0" tIns="0" rIns="0" bIns="0" rtlCol="0" anchor="ctr"/>
+          <a:lstStyle/>
+          <a:p>
+            <a:pPr indent="0" marL="0">
+              <a:buNone/>
+            </a:pPr>
+            <a:r>
+              <a:rPr lang="en-US" sz="900" u="sng" dirty="0">
                 <a:solidFill>
                   <a:srgbClr val="C4B5FD"/>
                 </a:solidFill>
                 <a:latin typeface="Calibri" pitchFamily="34" charset="0"/>
                 <a:ea typeface="Calibri" pitchFamily="34" charset="-122"/>
                 <a:cs typeface="Calibri" pitchFamily="34" charset="-120"/>
-              </a:rPr>
-              <a:t>GitHub  </a:t>
-            </a:r>
+                <a:hlinkClick r:id="rId4" invalidUrl="" action="" tgtFrame="" tooltip="" history="1" highlightClick="0" endSnd="0">
+                  <a:extLst>
+                    <a:ext uri="{A12FA001-AC4F-418D-AE19-62706E023703}">
+                      <ahyp:hlinkClr xmlns:ahyp="http://schemas.microsoft.com/office/drawing/2018/hyperlinkcolor" val="tx"/>
+                    </a:ext>
+                  </a:extLst>
+                </a:hlinkClick>
+              </a:rPr>
+              <a:t>qoneqt-video-factory.up.railway.app</a:t>
+            </a:r>
+            <a:endParaRPr lang="en-US" sz="900" dirty="0"/>
+          </a:p>
+        </p:txBody>
+      </p:sp>
+      <p:sp>
+        <p:nvSpPr>
+          <p:cNvPr id="22" name="Text 19"/>
+          <p:cNvSpPr txBox="1"/>
+          <p:nvPr/>
+        </p:nvSpPr>
+        <p:spPr>
+          <a:xfrm>
+            <a:off x="4023360" y="4114800"/>
+            <a:ext cx="4663440" cy="502920"/>
+          </a:xfrm>
+          <a:prstGeom prst="rect">
+            <a:avLst/>
+          </a:prstGeom>
+          <a:noFill/>
+          <a:ln/>
+        </p:spPr>
+        <p:txBody>
+          <a:bodyPr wrap="square" lIns="0" tIns="0" rIns="0" bIns="0" rtlCol="0" anchor="ctr"/>
+          <a:lstStyle/>
+          <a:p>
             <a:pPr indent="0" marL="0">
               <a:buNone/>
             </a:pPr>
             <a:r>
-              <a:rPr lang="en-US" sz="1050" dirty="0">
-                <a:solidFill>
-                  <a:srgbClr val="FFE500"/>
-                </a:solidFill>
-                <a:latin typeface="Calibri" pitchFamily="34" charset="0"/>
-                <a:ea typeface="Calibri" pitchFamily="34" charset="-122"/>
-                <a:cs typeface="Calibri" pitchFamily="34" charset="-120"/>
-              </a:rPr>
-              <a:t>github.com/&lt;user&gt;/qoneqt-video-factory</a:t>
-            </a:r>
-            <a:pPr indent="0" marL="0">
-              <a:buNone/>
-            </a:pPr>
-            <a:endParaRPr lang="en-US" sz="1050" dirty="0"/>
-          </a:p>
-          <a:p>
-            <a:pPr indent="0" marL="0">
-              <a:buNone/>
-            </a:pPr>
-            <a:r>
-              <a:rPr lang="en-US" sz="1050" b="1" dirty="0">
-                <a:solidFill>
-                  <a:srgbClr val="C4B5FD"/>
-                </a:solidFill>
-                <a:latin typeface="Calibri" pitchFamily="34" charset="0"/>
-                <a:ea typeface="Calibri" pitchFamily="34" charset="-122"/>
-                <a:cs typeface="Calibri" pitchFamily="34" charset="-120"/>
-              </a:rPr>
-              <a:t>Live demo  </a:t>
-            </a:r>
-            <a:endParaRPr lang="en-US" sz="1050" dirty="0"/>
-          </a:p>
-          <a:p>
-            <a:pPr indent="0" marL="0">
-              <a:buNone/>
-            </a:pPr>
-            <a:r>
-              <a:rPr lang="en-US" sz="1050" dirty="0">
-                <a:solidFill>
-                  <a:srgbClr val="FFE500"/>
-                </a:solidFill>
-                <a:latin typeface="Calibri" pitchFamily="34" charset="0"/>
-                <a:ea typeface="Calibri" pitchFamily="34" charset="-122"/>
-                <a:cs typeface="Calibri" pitchFamily="34" charset="-120"/>
-              </a:rPr>
-              <a:t>huggingface.co/spaces/&lt;user&gt;/qoneqt-video-factory</a:t>
-            </a:r>
-            <a:endParaRPr lang="en-US" sz="1050" dirty="0"/>
-          </a:p>
-        </p:txBody>
-      </p:sp>
-      <p:sp>
-        <p:nvSpPr>
-          <p:cNvPr id="11" name="Text 8"/>
-          <p:cNvSpPr txBox="1"/>
-          <p:nvPr/>
-        </p:nvSpPr>
-        <p:spPr>
-          <a:xfrm>
-            <a:off x="4023360" y="3639312"/>
-            <a:ext cx="4663440" cy="502920"/>
-          </a:xfrm>
-          <a:prstGeom prst="rect">
-            <a:avLst/>
-          </a:prstGeom>
-          <a:noFill/>
-          <a:ln/>
-        </p:spPr>
-        <p:txBody>
-          <a:bodyPr wrap="square" lIns="0" tIns="0" rIns="0" bIns="0" rtlCol="0" anchor="ctr"/>
-          <a:lstStyle/>
-          <a:p>
-            <a:pPr indent="0" marL="0">
-              <a:buNone/>
-            </a:pPr>
-            <a:r>
-              <a:rPr lang="en-US" sz="1500" b="1" i="1" dirty="0">
+              <a:rPr lang="en-US" sz="1250" b="1" i="1" dirty="0">
                 <a:solidFill>
                   <a:srgbClr val="FFFFFF"/>
                 </a:solidFill>
@@ -9772,46 +10151,7 @@
               </a:rPr>
               <a:t>Qoneqt doesn't need one AI video. It needs a factory. We built the factory.</a:t>
             </a:r>
-            <a:endParaRPr lang="en-US" sz="1500" dirty="0"/>
-          </a:p>
-        </p:txBody>
-      </p:sp>
-      <p:sp>
-        <p:nvSpPr>
-          <p:cNvPr id="12" name="Text 9"/>
-          <p:cNvSpPr txBox="1"/>
-          <p:nvPr/>
-        </p:nvSpPr>
-        <p:spPr>
-          <a:xfrm>
-            <a:off x="4023360" y="4187952"/>
-            <a:ext cx="4663440" cy="502920"/>
-          </a:xfrm>
-          <a:prstGeom prst="rect">
-            <a:avLst/>
-          </a:prstGeom>
-          <a:noFill/>
-          <a:ln/>
-        </p:spPr>
-        <p:txBody>
-          <a:bodyPr wrap="square" lIns="0" tIns="0" rIns="0" bIns="0" rtlCol="0" anchor="t"/>
-          <a:lstStyle/>
-          <a:p>
-            <a:pPr indent="0" marL="0">
-              <a:buNone/>
-            </a:pPr>
-            <a:r>
-              <a:rPr lang="en-US" sz="1000" dirty="0">
-                <a:solidFill>
-                  <a:srgbClr val="F3EEFC"/>
-                </a:solidFill>
-                <a:latin typeface="Calibri" pitchFamily="34" charset="0"/>
-                <a:ea typeface="Calibri" pitchFamily="34" charset="-122"/>
-                <a:cs typeface="Calibri" pitchFamily="34" charset="-120"/>
-              </a:rPr>
-              <a:t>Why select this: it already ships, costs nothing to run, speaks each community's language, and is built on Qoneqt's real content format, not a concept.</a:t>
-            </a:r>
-            <a:endParaRPr lang="en-US" sz="1000" dirty="0"/>
+            <a:endParaRPr lang="en-US" sz="1250" dirty="0"/>
           </a:p>
         </p:txBody>
       </p:sp>

</xml_diff>